<commit_message>
Aktualizacja prezentacji: scenka z gry, logotypy partnerów, nowe logo i poprawki ról
</commit_message>
<xml_diff>
--- a/Cienie-Rzeczypospolitej-prezentacja-finalna.pptx
+++ b/Cienie-Rzeczypospolitej-prezentacja-finalna.pptx
@@ -722,12 +722,17 @@
           <a:p/>
           <a:p>
             <a:r>
-              <a:t>- Rozdziel: AI (Claude Code do kodu, Gemini Nano Banana 2 Pro do grafik) i nasza praca.</a:t>
-            </a:r>
-          </a:p>
-          <a:p>
-            <a:r>
-              <a:t>- Stos: Next.js 16, React 19, Unity WebGL dla mapy. Ta prezentacja jest stroną z platformy.</a:t>
+              <a:t>- Rozdziel: AI (Claude Code do kodu, Gemini do grafik) i nasza praca.</a:t>
+            </a:r>
+          </a:p>
+          <a:p>
+            <a:r>
+              <a:t>- Stos: Next.js, React, TypeScript, Tailwind CSS. Aplikacja webowa działa w przeglądarce.</a:t>
+            </a:r>
+          </a:p>
+          <a:p>
+            <a:r>
+              <a:t>- Treści historyczne pochodzą ze sprawdzonych źródeł, nie z AI.</a:t>
             </a:r>
           </a:p>
         </p:txBody>
@@ -813,12 +818,12 @@
           <a:p/>
           <a:p>
             <a:r>
-              <a:t>- Cztery kroki: nauczyciele, muzea i domy kultury, kolejne lekcje, promocja.</a:t>
-            </a:r>
-          </a:p>
-          <a:p>
-            <a:r>
-              <a:t>- Mów tylko to, co jest prawdą o kontaktach z muzeami.</a:t>
+              <a:t>- Cztery filary dalszego rozwoju: współpraca ze szkołami, partnerstwo merytoryczne z Domem Współpracy Polsko-Niemieckiej,</a:t>
+            </a:r>
+          </a:p>
+          <a:p>
+            <a:r>
+              <a:t>- partnerstwo technologiczne z Fundacją Generacja Innowacja oraz kolejne lekcje i wdrożenia.</a:t>
             </a:r>
           </a:p>
         </p:txBody>
@@ -1525,7 +1530,7 @@
           <a:lstStyle/>
           <a:p>
             <a:r>
-              <a:t>Mówi: Michał, cała sala</a:t>
+              <a:t>Mówi: Michał</a:t>
             </a:r>
           </a:p>
           <a:p>
@@ -1541,12 +1546,17 @@
           <a:p/>
           <a:p>
             <a:r>
-              <a:t>- Jury podnosi rękę: 1, 2 albo 3. Wciśnij klawisz 1/2/3 i pokaż odpowiedź gry.</a:t>
-            </a:r>
-          </a:p>
-          <a:p>
-            <a:r>
-              <a:t>- Puenta: tak samo wybiera każdy uczeń i od razu widzi konsekwencje.</a:t>
+              <a:t>- Przykładowa scena z gry: rozkaz marszałka Koniewa w bunkrze pod Gogolinem.</a:t>
+            </a:r>
+          </a:p>
+          <a:p>
+            <a:r>
+              <a:t>- Pokaż trzy opcje odpowiedzi zwiadowcy (1, 2, 3) i reakcję gry na każdą z nich.</a:t>
+            </a:r>
+          </a:p>
+          <a:p>
+            <a:r>
+              <a:t>- Puenta: uczeń staje przed realnym dylematem moralnym i od razu widzi konsekwencje swoich decyzji.</a:t>
             </a:r>
           </a:p>
           <a:p>
@@ -1637,12 +1647,12 @@
           <a:p/>
           <a:p>
             <a:r>
-              <a:t>- Slajd z odpowiedziami gry: wskaż tę, którą wybrało jury, i przeczytaj odpowiedź Koniewa.</a:t>
-            </a:r>
-          </a:p>
-          <a:p>
-            <a:r>
-              <a:t>- Puenta: każdy uczeń staje przed takim wyborem i od razu widzi konsekwencje.</a:t>
+              <a:t>- Slajd z odpowiedziami gry: omów reakcję Koniewa na poszczególne decyzje zwiadowcy.</a:t>
+            </a:r>
+          </a:p>
+          <a:p>
+            <a:r>
+              <a:t>- Puenta: każdy uczeń staje przed takim dylematem i od razu widzi konsekwencje.</a:t>
             </a:r>
           </a:p>
           <a:p>

</xml_diff>